<commit_message>
Add explainer video for how-to-convert-powerpoint-to-video-the-complete-guide
</commit_message>
<xml_diff>
--- a/studio/blog/how-to-convert-powerpoint-to-video-the-complete-guide/input-deck.pptx
+++ b/studio/blog/how-to-convert-powerpoint-to-video-the-complete-guide/input-deck.pptx
@@ -507,7 +507,7 @@
           <a:lstStyle/>
           <a:p>
             <a:r>
-              <a:t>Your slide deck already explains something well. Here's how to make it work without you in the room, from tidying the deck to sharing the finished file.</a:t>
+              <a:t>Your slide deck already explains something well. Here's how to make it work without you in the room, by turning it into a video.</a:t>
             </a:r>
           </a:p>
         </p:txBody>
@@ -577,7 +577,7 @@
           <a:lstStyle/>
           <a:p>
             <a:r>
-              <a:t>A deck on its own relies on a presenter. A video carries the slides and the explanation, so viewers can watch whenever suits them.</a:t>
+              <a:t>A deck on its own relies on a presenter. A video carries the slides and the explanation, and anyone can watch whenever suits them.</a:t>
             </a:r>
           </a:p>
         </p:txBody>
@@ -647,7 +647,7 @@
           <a:lstStyle/>
           <a:p>
             <a:r>
-              <a:t>You can export from PowerPoint and record yourself, or screen record a run-through. A dedicated converter builds the video from your notes, so updates are easy.</a:t>
+              <a:t>You can export from PowerPoint, record your screen, or use a dedicated converter that builds the video from your notes. Each one has its place.</a:t>
             </a:r>
           </a:p>
         </p:txBody>
@@ -717,7 +717,7 @@
           <a:lstStyle/>
           <a:p>
             <a:r>
-              <a:t>Ten minutes of tidying saves a lot of re-exporting. Keep one idea per slide, and make each headline the point, like 'Returns are processed within five days'.</a:t>
+              <a:t>Tidy the deck first. Keep one idea per slide, make each headline the point, and move detail into the speaker notes, where it becomes narration.</a:t>
             </a:r>
           </a:p>
         </p:txBody>
@@ -787,7 +787,7 @@
           <a:lstStyle/>
           <a:p>
             <a:r>
-              <a:t>Your speaker notes are your script. Write them as spoken sentences, not reminders. The longer version is much easier to follow by ear.</a:t>
+              <a:t>Your speaker notes are your script. Write them as spoken sentences, not reminders. They run longer, but they're much easier to follow by ear.</a:t>
             </a:r>
           </a:p>
         </p:txBody>
@@ -857,7 +857,7 @@
           <a:lstStyle/>
           <a:p>
             <a:r>
-              <a:t>Upload your deck and pick a voice. Try it on Basic first. On Pro, a.i. directs your video with animated scenes and a tighter story. Visit powerpoint2vid.com.</a:t>
+              <a:t>Upload your deck and pick a voice. Try Basic first. On Pro, a.i. directs it into an explainer with animated scenes and a tighter story. Visit powerpoint2vid.com.</a:t>
             </a:r>
           </a:p>
         </p:txBody>
@@ -3950,7 +3950,7 @@
           <a:lstStyle/>
           <a:p>
             <a:r>
-              <a:t>A video explains itself</a:t>
+              <a:t>A video explains itself and travels</a:t>
             </a:r>
           </a:p>
         </p:txBody>
@@ -4156,7 +4156,7 @@
           </a:p>
           <a:p>
             <a:r>
-              <a:t>Use a 16:9 layout</a:t>
+              <a:t>16:9 layout with good contrast</a:t>
             </a:r>
           </a:p>
         </p:txBody>
@@ -4226,7 +4226,7 @@
           <a:lstStyle/>
           <a:p>
             <a:r>
-              <a:t>Before: "Day 1 - laptop, accts, buddy intro"</a:t>
+              <a:t>Before: "Day 1 - laptop, accts (email, HRIS), buddy intro."</a:t>
             </a:r>
           </a:p>
           <a:p>
@@ -4237,11 +4237,6 @@
           <a:p>
             <a:r>
               <a:t>Short sentences, spoken words</a:t>
-            </a:r>
-          </a:p>
-          <a:p>
-            <a:r>
-              <a:t>Spell out abbreviations</a:t>
             </a:r>
           </a:p>
         </p:txBody>
@@ -4285,7 +4280,7 @@
           <a:lstStyle/>
           <a:p>
             <a:r>
-              <a:t>Ordinary slides in, extraordinary video out</a:t>
+              <a:t>Ordinary deck in, explainer video out</a:t>
             </a:r>
           </a:p>
         </p:txBody>
@@ -4321,12 +4316,12 @@
           </a:p>
           <a:p>
             <a:r>
-              <a:t>Try it on Basic first</a:t>
-            </a:r>
-          </a:p>
-          <a:p>
-            <a:r>
-              <a:t>Pro: a.i.-directed, no watermark</a:t>
+              <a:t>Download the MP4</a:t>
+            </a:r>
+          </a:p>
+          <a:p>
+            <a:r>
+              <a:t>Try Basic first</a:t>
             </a:r>
           </a:p>
         </p:txBody>

</xml_diff>